<commit_message>
Finalize scalable solver submission with corrected report mathematics
</commit_message>
<xml_diff>
--- a/reports/final_presentation.pptx
+++ b/reports/final_presentation.pptx
@@ -2,19 +2,19 @@
 <file path=ppt/presentation.xml><?xml version="1.0" encoding="utf-8"?>
 <p:presentation xmlns:p="http://schemas.openxmlformats.org/presentationml/2006/main">
   <p:sldMasterIdLst>
-    <p:sldMasterId xmlns:r="http://schemas.openxmlformats.org/officeDocument/2006/relationships" id="2147483648" r:id="R5e62caa8b69f478b"/>
+    <p:sldMasterId xmlns:r="http://schemas.openxmlformats.org/officeDocument/2006/relationships" id="2147483648" r:id="Rbb33ef847a4447d6"/>
   </p:sldMasterIdLst>
   <p:notesMasterIdLst>
-    <p:notesMasterId xmlns:r="http://schemas.openxmlformats.org/officeDocument/2006/relationships" r:id="Ra79269af99c34462"/>
+    <p:notesMasterId xmlns:r="http://schemas.openxmlformats.org/officeDocument/2006/relationships" r:id="Rc46da091cba84ed1"/>
   </p:notesMasterIdLst>
   <p:sldIdLst>
-    <p:sldId xmlns:r="http://schemas.openxmlformats.org/officeDocument/2006/relationships" id="256" r:id="Rea6b95d51d054709"/>
-    <p:sldId xmlns:r="http://schemas.openxmlformats.org/officeDocument/2006/relationships" id="257" r:id="Ra1adf68a9c8f4681"/>
-    <p:sldId xmlns:r="http://schemas.openxmlformats.org/officeDocument/2006/relationships" id="258" r:id="R35e3b3f781c647a4"/>
-    <p:sldId xmlns:r="http://schemas.openxmlformats.org/officeDocument/2006/relationships" id="259" r:id="Rc8b6ff584d6248dd"/>
-    <p:sldId xmlns:r="http://schemas.openxmlformats.org/officeDocument/2006/relationships" id="260" r:id="R9dd6d828c40e46f4"/>
-    <p:sldId xmlns:r="http://schemas.openxmlformats.org/officeDocument/2006/relationships" id="261" r:id="R2e4e3fc22a00476e"/>
-    <p:sldId xmlns:r="http://schemas.openxmlformats.org/officeDocument/2006/relationships" id="262" r:id="R27873905a88b48c6"/>
+    <p:sldId xmlns:r="http://schemas.openxmlformats.org/officeDocument/2006/relationships" id="256" r:id="R1c3f45d2b527480d"/>
+    <p:sldId xmlns:r="http://schemas.openxmlformats.org/officeDocument/2006/relationships" id="257" r:id="R305ae845c5b4493d"/>
+    <p:sldId xmlns:r="http://schemas.openxmlformats.org/officeDocument/2006/relationships" id="258" r:id="R9441bf2ef28c4dfb"/>
+    <p:sldId xmlns:r="http://schemas.openxmlformats.org/officeDocument/2006/relationships" id="259" r:id="Ra44b192197384d5e"/>
+    <p:sldId xmlns:r="http://schemas.openxmlformats.org/officeDocument/2006/relationships" id="260" r:id="Rb41426cb49b648f6"/>
+    <p:sldId xmlns:r="http://schemas.openxmlformats.org/officeDocument/2006/relationships" id="261" r:id="Rca8dfe0967754985"/>
+    <p:sldId xmlns:r="http://schemas.openxmlformats.org/officeDocument/2006/relationships" id="262" r:id="R05b14d827c3545eb"/>
   </p:sldIdLst>
   <p:sldSz cx="12192000" cy="6858000"/>
   <p:notesSz cx="6858000" cy="9144000"/>
@@ -448,32 +448,32 @@
           <a:lstStyle xmlns:a="http://schemas.openxmlformats.org/drawingml/2006/main"/>
           <a:p xmlns:a="http://schemas.openxmlformats.org/drawingml/2006/main">
             <a:r>
-              <a:t>Open with the operating decision: allocate finite inventory to order groups while preserving hard constraints.</a:t>
-            </a:r>
-          </a:p>
-          <a:p xmlns:a="http://schemas.openxmlformats.org/drawingml/2006/main">
-            <a:r>
-              <a:t>The hybrid contribution is a reliable classical pipeline with an optional quantum neighborhood sampler—not a quantum-advantage claim.</a:t>
-            </a:r>
-          </a:p>
-          <a:p xmlns:a="http://schemas.openxmlformats.org/drawingml/2006/main">
-            <a:r>
               <a:t>[Sources]</a:t>
             </a:r>
           </a:p>
           <a:p xmlns:a="http://schemas.openxmlformats.org/drawingml/2006/main">
             <a:r>
-              <a:t>results/final/aggregate_results.csv</a:t>
-            </a:r>
-          </a:p>
-          <a:p xmlns:a="http://schemas.openxmlformats.org/drawingml/2006/main">
-            <a:r>
-              <a:t>results/final/ibm/ibm_hardware_stress.csv</a:t>
-            </a:r>
-          </a:p>
-          <a:p xmlns:a="http://schemas.openxmlformats.org/drawingml/2006/main">
-            <a:r>
-              <a:t>reports/final_report.md</a:t>
+              <a:t>- reports/challenge_submission_report.md</a:t>
+            </a:r>
+          </a:p>
+          <a:p xmlns:a="http://schemas.openxmlformats.org/drawingml/2006/main">
+            <a:r>
+              <a:t>- reports/final_report.md</a:t>
+            </a:r>
+          </a:p>
+          <a:p xmlns:a="http://schemas.openxmlformats.org/drawingml/2006/main">
+            <a:r>
+              <a:t>[/Sources]</a:t>
+            </a:r>
+          </a:p>
+          <a:p xmlns:a="http://schemas.openxmlformats.org/drawingml/2006/main">
+            <a:r>
+              <a:t/>
+            </a:r>
+          </a:p>
+          <a:p xmlns:a="http://schemas.openxmlformats.org/drawingml/2006/main">
+            <a:r>
+              <a:t>Open with the audited scope: 516 rows, 513 validated plans, and the final scaling/hardware matrix.</a:t>
             </a:r>
           </a:p>
         </p:txBody>
@@ -543,37 +543,32 @@
           <a:lstStyle xmlns:a="http://schemas.openxmlformats.org/drawingml/2006/main"/>
           <a:p xmlns:a="http://schemas.openxmlformats.org/drawingml/2006/main">
             <a:r>
-              <a:t>ATP means inventory that can still be promised to customers after existing commitments.</a:t>
-            </a:r>
-          </a:p>
-          <a:p xmlns:a="http://schemas.openxmlformats.org/drawingml/2006/main">
-            <a:r>
-              <a:t>Objective capture in later slides is the achieved objective divided by total requested merchandise value; it is not an optimality gap.</a:t>
-            </a:r>
-          </a:p>
-          <a:p xmlns:a="http://schemas.openxmlformats.org/drawingml/2006/main">
-            <a:r>
               <a:t>[Sources]</a:t>
             </a:r>
           </a:p>
           <a:p xmlns:a="http://schemas.openxmlformats.org/drawingml/2006/main">
             <a:r>
-              <a:t>docs/mathematical_formulation.md</a:t>
-            </a:r>
-          </a:p>
-          <a:p xmlns:a="http://schemas.openxmlformats.org/drawingml/2006/main">
-            <a:r>
-              <a:t>docs/data_guide.md</a:t>
-            </a:r>
-          </a:p>
-          <a:p xmlns:a="http://schemas.openxmlformats.org/drawingml/2006/main">
-            <a:r>
-              <a:t>https://doi.org/10.1007/s10479-005-6235-7</a:t>
-            </a:r>
-          </a:p>
-          <a:p xmlns:a="http://schemas.openxmlformats.org/drawingml/2006/main">
-            <a:r>
-              <a:t>https://doi.org/10.1007/s10845-005-0003-z</a:t>
+              <a:t>- docs/data_guide.md</a:t>
+            </a:r>
+          </a:p>
+          <a:p xmlns:a="http://schemas.openxmlformats.org/drawingml/2006/main">
+            <a:r>
+              <a:t>- docs/mathematical_formulation.md</a:t>
+            </a:r>
+          </a:p>
+          <a:p xmlns:a="http://schemas.openxmlformats.org/drawingml/2006/main">
+            <a:r>
+              <a:t>[/Sources]</a:t>
+            </a:r>
+          </a:p>
+          <a:p xmlns:a="http://schemas.openxmlformats.org/drawingml/2006/main">
+            <a:r>
+              <a:t/>
+            </a:r>
+          </a:p>
+          <a:p xmlns:a="http://schemas.openxmlformats.org/drawingml/2006/main">
+            <a:r>
+              <a:t>Explain objective capture and why load cohesion plus cumulative ATP make the problem coupled.</a:t>
             </a:r>
           </a:p>
         </p:txBody>
@@ -643,57 +638,37 @@
           <a:lstStyle xmlns:a="http://schemas.openxmlformats.org/drawingml/2006/main"/>
           <a:p xmlns:a="http://schemas.openxmlformats.org/drawingml/2006/main">
             <a:r>
-              <a:t>Feasibility is never delegated to noisy hardware: samples propose moves, while deterministic decoding, recourse, and validation protect the operational solution.</a:t>
-            </a:r>
-          </a:p>
-          <a:p xmlns:a="http://schemas.openxmlformats.org/drawingml/2006/main">
-            <a:r>
-              <a:t>The strengthened implementation uses a scalable linear W-state circuit, a path-topology XY mixer, parameter reuse, and richer sampling-quality metrics.</a:t>
-            </a:r>
-          </a:p>
-          <a:p xmlns:a="http://schemas.openxmlformats.org/drawingml/2006/main">
-            <a:r>
               <a:t>[Sources]</a:t>
             </a:r>
           </a:p>
           <a:p xmlns:a="http://schemas.openxmlformats.org/drawingml/2006/main">
             <a:r>
-              <a:t>src/domopt/classical.py</a:t>
-            </a:r>
-          </a:p>
-          <a:p xmlns:a="http://schemas.openxmlformats.org/drawingml/2006/main">
-            <a:r>
-              <a:t>src/domopt/quantum.py</a:t>
-            </a:r>
-          </a:p>
-          <a:p xmlns:a="http://schemas.openxmlformats.org/drawingml/2006/main">
-            <a:r>
-              <a:t>src/domopt/hybrid.py</a:t>
-            </a:r>
-          </a:p>
-          <a:p xmlns:a="http://schemas.openxmlformats.org/drawingml/2006/main">
-            <a:r>
-              <a:t>src/domopt/hardware.py</a:t>
-            </a:r>
-          </a:p>
-          <a:p xmlns:a="http://schemas.openxmlformats.org/drawingml/2006/main">
-            <a:r>
-              <a:t>https://doi.org/10.3390/a12020034</a:t>
-            </a:r>
-          </a:p>
-          <a:p xmlns:a="http://schemas.openxmlformats.org/drawingml/2006/main">
-            <a:r>
-              <a:t>https://doi.org/10.1103/PhysRevA.101.012320</a:t>
-            </a:r>
-          </a:p>
-          <a:p xmlns:a="http://schemas.openxmlformats.org/drawingml/2006/main">
-            <a:r>
-              <a:t>https://doi.org/10.22331/q-2021-06-17-479</a:t>
-            </a:r>
-          </a:p>
-          <a:p xmlns:a="http://schemas.openxmlformats.org/drawingml/2006/main">
-            <a:r>
-              <a:t>https://doi.org/10.22331/q-2022-08-22-781</a:t>
+              <a:t>- docs/solver_method.md</a:t>
+            </a:r>
+          </a:p>
+          <a:p xmlns:a="http://schemas.openxmlformats.org/drawingml/2006/main">
+            <a:r>
+              <a:t>- src/domopt/hybrid.py</a:t>
+            </a:r>
+          </a:p>
+          <a:p xmlns:a="http://schemas.openxmlformats.org/drawingml/2006/main">
+            <a:r>
+              <a:t>- src/domopt/quantum.py</a:t>
+            </a:r>
+          </a:p>
+          <a:p xmlns:a="http://schemas.openxmlformats.org/drawingml/2006/main">
+            <a:r>
+              <a:t>[/Sources]</a:t>
+            </a:r>
+          </a:p>
+          <a:p xmlns:a="http://schemas.openxmlformats.org/drawingml/2006/main">
+            <a:r>
+              <a:t/>
+            </a:r>
+          </a:p>
+          <a:p xmlns:a="http://schemas.openxmlformats.org/drawingml/2006/main">
+            <a:r>
+              <a:t>Emphasize that samplers propose; exact recourse and the validator accept or reject.</a:t>
             </a:r>
           </a:p>
         </p:txBody>
@@ -763,32 +738,37 @@
           <a:lstStyle xmlns:a="http://schemas.openxmlformats.org/drawingml/2006/main"/>
           <a:p xmlns:a="http://schemas.openxmlformats.org/drawingml/2006/main">
             <a:r>
-              <a:t>Polishing gains about 3.51 percentage points of objective capture over the historical default and matches the complete MILP on the common 20-group subset.</a:t>
-            </a:r>
-          </a:p>
-          <a:p xmlns:a="http://schemas.openxmlformats.org/drawingml/2006/main">
-            <a:r>
-              <a:t>Exact LNS and simulated annealing do not add value on this easy real subset, but coordinated search adds 197.2 objective units on the constructed trap.</a:t>
-            </a:r>
-          </a:p>
-          <a:p xmlns:a="http://schemas.openxmlformats.org/drawingml/2006/main">
-            <a:r>
               <a:t>[Sources]</a:t>
             </a:r>
           </a:p>
           <a:p xmlns:a="http://schemas.openxmlformats.org/drawingml/2006/main">
             <a:r>
-              <a:t>results/final/tables/solver_comparison.csv</a:t>
-            </a:r>
-          </a:p>
-          <a:p xmlns:a="http://schemas.openxmlformats.org/drawingml/2006/main">
-            <a:r>
-              <a:t>results/final/tables/synthetic_coordination_control.csv</a:t>
-            </a:r>
-          </a:p>
-          <a:p xmlns:a="http://schemas.openxmlformats.org/drawingml/2006/main">
-            <a:r>
-              <a:t>results/final/figures/submission_solver_summary.png</a:t>
+              <a:t>- results/final/figures/submission_solver_summary.png</a:t>
+            </a:r>
+          </a:p>
+          <a:p xmlns:a="http://schemas.openxmlformats.org/drawingml/2006/main">
+            <a:r>
+              <a:t>- results/final/figures/submission_coordination_summary.png</a:t>
+            </a:r>
+          </a:p>
+          <a:p xmlns:a="http://schemas.openxmlformats.org/drawingml/2006/main">
+            <a:r>
+              <a:t>- reports/challenge_submission_report.md</a:t>
+            </a:r>
+          </a:p>
+          <a:p xmlns:a="http://schemas.openxmlformats.org/drawingml/2006/main">
+            <a:r>
+              <a:t>[/Sources]</a:t>
+            </a:r>
+          </a:p>
+          <a:p xmlns:a="http://schemas.openxmlformats.org/drawingml/2006/main">
+            <a:r>
+              <a:t/>
+            </a:r>
+          </a:p>
+          <a:p xmlns:a="http://schemas.openxmlformats.org/drawingml/2006/main">
+            <a:r>
+              <a:t>The full MILP is time-limited and has a nonzero gap; do not call that row exact.</a:t>
             </a:r>
           </a:p>
         </p:txBody>
@@ -858,37 +838,32 @@
           <a:lstStyle xmlns:a="http://schemas.openxmlformats.org/drawingml/2006/main"/>
           <a:p xmlns:a="http://schemas.openxmlformats.org/drawingml/2006/main">
             <a:r>
-              <a:t>The code now exposes Gurobi as an explicit optional backend and checks result parity when both solvers are available.</a:t>
-            </a:r>
-          </a:p>
-          <a:p xmlns:a="http://schemas.openxmlformats.org/drawingml/2006/main">
-            <a:r>
-              <a:t>The default remains SciPy/HiGHS because it is license-free and distributed on Windows, macOS, and Linux through the Python stack.</a:t>
-            </a:r>
-          </a:p>
-          <a:p xmlns:a="http://schemas.openxmlformats.org/drawingml/2006/main">
-            <a:r>
               <a:t>[Sources]</a:t>
             </a:r>
           </a:p>
           <a:p xmlns:a="http://schemas.openxmlformats.org/drawingml/2006/main">
             <a:r>
-              <a:t>results/final/tables/size_scaling.csv</a:t>
-            </a:r>
-          </a:p>
-          <a:p xmlns:a="http://schemas.openxmlformats.org/drawingml/2006/main">
-            <a:r>
-              <a:t>notebooks/nestle_challenge_experiments.ipynb</a:t>
-            </a:r>
-          </a:p>
-          <a:p xmlns:a="http://schemas.openxmlformats.org/drawingml/2006/main">
-            <a:r>
-              <a:t>https://highs.dev/</a:t>
-            </a:r>
-          </a:p>
-          <a:p xmlns:a="http://schemas.openxmlformats.org/drawingml/2006/main">
-            <a:r>
-              <a:t>https://docs.gurobi.com/current/#refman/index.html</a:t>
+              <a:t>- results/final/figures/submission_scaling_summary.png</a:t>
+            </a:r>
+          </a:p>
+          <a:p xmlns:a="http://schemas.openxmlformats.org/drawingml/2006/main">
+            <a:r>
+              <a:t>- reports/final_report.md</a:t>
+            </a:r>
+          </a:p>
+          <a:p xmlns:a="http://schemas.openxmlformats.org/drawingml/2006/main">
+            <a:r>
+              <a:t>[/Sources]</a:t>
+            </a:r>
+          </a:p>
+          <a:p xmlns:a="http://schemas.openxmlformats.org/drawingml/2006/main">
+            <a:r>
+              <a:t/>
+            </a:r>
+          </a:p>
+          <a:p xmlns:a="http://schemas.openxmlformats.org/drawingml/2006/main">
+            <a:r>
+              <a:t>At 372 real groups the local hybrid QUBO is at most 16 variables; generated scaling reaches 32.</a:t>
             </a:r>
           </a:p>
         </p:txBody>
@@ -958,42 +933,37 @@
           <a:lstStyle xmlns:a="http://schemas.openxmlformats.org/drawingml/2006/main"/>
           <a:p xmlns:a="http://schemas.openxmlformats.org/drawingml/2006/main">
             <a:r>
-              <a:t>IBM Marrakesh has 156 qubits; the reported experiment used 16 logical qubits, 512 shots, 18 QPU jobs, and three repetitions per configuration.</a:t>
-            </a:r>
-          </a:p>
-          <a:p xmlns:a="http://schemas.openxmlformats.org/drawingml/2006/main">
-            <a:r>
-              <a:t>At depth one the raw one-hot rate is materially higher. At depth two the circuit is much deeper and noisier, despite improved ideal simulation.</a:t>
-            </a:r>
-          </a:p>
-          <a:p xmlns:a="http://schemas.openxmlformats.org/drawingml/2006/main">
-            <a:r>
-              <a:t>Every final allocation is feasible because deterministic recourse and validation remain outside the quantum circuit.</a:t>
-            </a:r>
-          </a:p>
-          <a:p xmlns:a="http://schemas.openxmlformats.org/drawingml/2006/main">
-            <a:r>
               <a:t>[Sources]</a:t>
             </a:r>
           </a:p>
           <a:p xmlns:a="http://schemas.openxmlformats.org/drawingml/2006/main">
             <a:r>
-              <a:t>results/final/ibm/ibm_hardware_stress.csv</a:t>
-            </a:r>
-          </a:p>
-          <a:p xmlns:a="http://schemas.openxmlformats.org/drawingml/2006/main">
-            <a:r>
-              <a:t>results/final/ibm/ibm_hardware_stress.manifest.json</a:t>
-            </a:r>
-          </a:p>
-          <a:p xmlns:a="http://schemas.openxmlformats.org/drawingml/2006/main">
-            <a:r>
-              <a:t>results/final/figures/submission_ibm_depth_summary.png</a:t>
-            </a:r>
-          </a:p>
-          <a:p xmlns:a="http://schemas.openxmlformats.org/drawingml/2006/main">
-            <a:r>
-              <a:t>https://quantum.cloud.ibm.com/docs/en/guides/qaoa</a:t>
+              <a:t>- results/final/figures/submission_ibm_depth_summary.png</a:t>
+            </a:r>
+          </a:p>
+          <a:p xmlns:a="http://schemas.openxmlformats.org/drawingml/2006/main">
+            <a:r>
+              <a:t>- results/final/ibm/figures/ibm_hardware_stress.png</a:t>
+            </a:r>
+          </a:p>
+          <a:p xmlns:a="http://schemas.openxmlformats.org/drawingml/2006/main">
+            <a:r>
+              <a:t>- reports/final_report.md</a:t>
+            </a:r>
+          </a:p>
+          <a:p xmlns:a="http://schemas.openxmlformats.org/drawingml/2006/main">
+            <a:r>
+              <a:t>[/Sources]</a:t>
+            </a:r>
+          </a:p>
+          <a:p xmlns:a="http://schemas.openxmlformats.org/drawingml/2006/main">
+            <a:r>
+              <a:t/>
+            </a:r>
+          </a:p>
+          <a:p xmlns:a="http://schemas.openxmlformats.org/drawingml/2006/main">
+            <a:r>
+              <a:t>QAOA is the proposal method. ibm_marrakesh is the processor/execution target. Queue time is separate from execution.</a:t>
             </a:r>
           </a:p>
         </p:txBody>
@@ -1063,47 +1033,37 @@
           <a:lstStyle xmlns:a="http://schemas.openxmlformats.org/drawingml/2006/main"/>
           <a:p xmlns:a="http://schemas.openxmlformats.org/drawingml/2006/main">
             <a:r>
-              <a:t>Close with the deployment recommendation: use the classical hybrid immediately, reserve expensive exact or quantum work for detected hard neighborhoods, and keep the quantum track falsifiable.</a:t>
-            </a:r>
-          </a:p>
-          <a:p xmlns:a="http://schemas.openxmlformats.org/drawingml/2006/main">
-            <a:r>
-              <a:t>The next credible hardware milestone is not more qubits alone—it is higher feasible-sample quality at comparable circuit depth and a measurable gain before deterministic recourse.</a:t>
-            </a:r>
-          </a:p>
-          <a:p xmlns:a="http://schemas.openxmlformats.org/drawingml/2006/main">
-            <a:r>
               <a:t>[Sources]</a:t>
             </a:r>
           </a:p>
           <a:p xmlns:a="http://schemas.openxmlformats.org/drawingml/2006/main">
             <a:r>
-              <a:t>reports/final_report.md</a:t>
-            </a:r>
-          </a:p>
-          <a:p xmlns:a="http://schemas.openxmlformats.org/drawingml/2006/main">
-            <a:r>
-              <a:t>reports/business_technical_summary.md</a:t>
-            </a:r>
-          </a:p>
-          <a:p xmlns:a="http://schemas.openxmlformats.org/drawingml/2006/main">
-            <a:r>
-              <a:t>docs/challenge_checklist.md</a:t>
-            </a:r>
-          </a:p>
-          <a:p xmlns:a="http://schemas.openxmlformats.org/drawingml/2006/main">
-            <a:r>
-              <a:t>https://doi.org/10.1007/3-540-49481-2_30</a:t>
-            </a:r>
-          </a:p>
-          <a:p xmlns:a="http://schemas.openxmlformats.org/drawingml/2006/main">
-            <a:r>
-              <a:t>https://doi.org/10.1007/s10107-003-0395-5</a:t>
-            </a:r>
-          </a:p>
-          <a:p xmlns:a="http://schemas.openxmlformats.org/drawingml/2006/main">
-            <a:r>
-              <a:t>https://doi.org/10.1007/s10107-004-0518-7</a:t>
+              <a:t>- reports/planner_view.md</a:t>
+            </a:r>
+          </a:p>
+          <a:p xmlns:a="http://schemas.openxmlformats.org/drawingml/2006/main">
+            <a:r>
+              <a:t>- README.md</a:t>
+            </a:r>
+          </a:p>
+          <a:p xmlns:a="http://schemas.openxmlformats.org/drawingml/2006/main">
+            <a:r>
+              <a:t>- docs/challenge_checklist.md</a:t>
+            </a:r>
+          </a:p>
+          <a:p xmlns:a="http://schemas.openxmlformats.org/drawingml/2006/main">
+            <a:r>
+              <a:t>[/Sources]</a:t>
+            </a:r>
+          </a:p>
+          <a:p xmlns:a="http://schemas.openxmlformats.org/drawingml/2006/main">
+            <a:r>
+              <a:t/>
+            </a:r>
+          </a:p>
+          <a:p xmlns:a="http://schemas.openxmlformats.org/drawingml/2006/main">
+            <a:r>
+              <a:t>Close on deployable classical value, a shadow-mode pilot, and a bounded measurement program for future QAOA.</a:t>
             </a:r>
           </a:p>
         </p:txBody>
@@ -1171,7 +1131,7 @@
   </p:cSld>
   <p:clrMap bg1="lt1" tx1="dk1" bg2="lt2" tx2="dk2" accent1="accent1" accent2="accent2" accent3="accent3" accent4="accent4" accent5="accent5" accent6="accent6" hlink="hlink" folHlink="folHlink"/>
   <p:sldLayoutIdLst>
-    <p:sldLayoutId xmlns:r="http://schemas.openxmlformats.org/officeDocument/2006/relationships" id="2147483649" r:id="R352ad8e95fff4a5f"/>
+    <p:sldLayoutId xmlns:r="http://schemas.openxmlformats.org/officeDocument/2006/relationships" id="2147483649" r:id="R07ae2ce8f4234b66"/>
   </p:sldLayoutIdLst>
   <p:txStyles>
     <p:titleStyle>
@@ -2516,7 +2476,7 @@
                 <a:ea typeface="Arial"/>
                 <a:cs typeface="Arial"/>
               </a:rPr>
-              <a:t>Hybrid order</a:t>
+              <a:t>Scalable, safeguarded</a:t>
             </a:r>
           </a:p>
           <a:p xmlns:a="http://schemas.openxmlformats.org/drawingml/2006/main">
@@ -2540,7 +2500,7 @@
                 <a:ea typeface="Arial"/>
                 <a:cs typeface="Arial"/>
               </a:rPr>
-              <a:t>fulfillment optimization</a:t>
+              <a:t>DOM optimization</a:t>
             </a:r>
           </a:p>
         </p:txBody>
@@ -2599,7 +2559,7 @@
                 <a:ea typeface="Arial"/>
                 <a:cs typeface="Arial"/>
               </a:rPr>
-              <a:t>Fast feasible allocation with exact local improvement and honest quantum evidence.</a:t>
+              <a:t>A feasibility-first hierarchy from greedy planning to bounded QAOA proposals.</a:t>
             </a:r>
           </a:p>
         </p:txBody>
@@ -2658,7 +2618,7 @@
                 <a:ea typeface="Arial"/>
                 <a:cs typeface="Arial"/>
               </a:rPr>
-              <a:t>HiGHS baseline  •  MILP polish  •  constraint-aware QAOA neighborhoods</a:t>
+              <a:t>Greedy  •  exact recourse  •  exact LNS  •  bounded QUBO/QAOA</a:t>
             </a:r>
           </a:p>
         </p:txBody>
@@ -2903,7 +2863,7 @@
                 <a:ea typeface="Arial"/>
                 <a:cs typeface="Arial"/>
               </a:rPr>
-              <a:t>247 / 247</a:t>
+              <a:t>516</a:t>
             </a:r>
           </a:p>
         </p:txBody>
@@ -2962,7 +2922,7 @@
                 <a:ea typeface="Arial"/>
                 <a:cs typeface="Arial"/>
               </a:rPr>
-              <a:t>recorded result rows feasible</a:t>
+              <a:t>aggregate rows across 14 audited families</a:t>
             </a:r>
           </a:p>
         </p:txBody>
@@ -3056,7 +3016,7 @@
                 <a:ea typeface="Arial"/>
                 <a:cs typeface="Arial"/>
               </a:rPr>
-              <a:t>+197.2</a:t>
+              <a:t>+1.86 pp</a:t>
             </a:r>
           </a:p>
         </p:txBody>
@@ -3115,7 +3075,7 @@
                 <a:ea typeface="Arial"/>
                 <a:cs typeface="Arial"/>
               </a:rPr>
-              <a:t>objective gain on the coordinated-move trap</a:t>
+              <a:t>objective capture vs default on 100 groups</a:t>
             </a:r>
           </a:p>
         </p:txBody>
@@ -3209,7 +3169,7 @@
                 <a:ea typeface="Arial"/>
                 <a:cs typeface="Arial"/>
               </a:rPr>
-              <a:t>156 qubits</a:t>
+              <a:t>100k</a:t>
             </a:r>
           </a:p>
         </p:txBody>
@@ -3268,7 +3228,7 @@
                 <a:ea typeface="Arial"/>
                 <a:cs typeface="Arial"/>
               </a:rPr>
-              <a:t>IBM hardware study; 18 QPU jobs</a:t>
+              <a:t>generated orders: greedy + exact LNS</a:t>
             </a:r>
           </a:p>
         </p:txBody>
@@ -3303,7 +3263,7 @@
         </p:spPr>
         <p:txBody>
           <a:bodyPr xmlns:a="http://schemas.openxmlformats.org/drawingml/2006/main" lIns="0" tIns="0" rIns="0" bIns="0" anchor="t">
-            <a:normAutofit fontScale="100000"/>
+            <a:normAutofit fontScale="93963"/>
           </a:bodyPr>
           <a:lstStyle xmlns:a="http://schemas.openxmlformats.org/drawingml/2006/main"/>
           <a:p xmlns:a="http://schemas.openxmlformats.org/drawingml/2006/main">
@@ -3327,7 +3287,7 @@
                 <a:ea typeface="Arial"/>
                 <a:cs typeface="Arial"/>
               </a:rPr>
-              <a:t>16 canonical manifests verified</a:t>
+              <a:t>513 validated plans  •  18 QPU jobs  •  8,192 shots/job</a:t>
             </a:r>
           </a:p>
         </p:txBody>
@@ -3450,7 +3410,7 @@
         </p:spPr>
         <p:txBody>
           <a:bodyPr xmlns:a="http://schemas.openxmlformats.org/drawingml/2006/main" lIns="0" tIns="0" rIns="0" bIns="0" anchor="t">
-            <a:normAutofit fontScale="85903"/>
+            <a:normAutofit fontScale="100000"/>
           </a:bodyPr>
           <a:lstStyle xmlns:a="http://schemas.openxmlformats.org/drawingml/2006/main"/>
           <a:p xmlns:a="http://schemas.openxmlformats.org/drawingml/2006/main">
@@ -3474,7 +3434,7 @@
                 <a:ea typeface="Arial"/>
                 <a:cs typeface="Arial"/>
               </a:rPr>
-              <a:t>The decision is a constrained allocation—not a single score</a:t>
+              <a:t>DOM is constrained allocation</a:t>
             </a:r>
           </a:p>
         </p:txBody>
@@ -3734,7 +3694,7 @@
         </p:spPr>
         <p:txBody>
           <a:bodyPr xmlns:a="http://schemas.openxmlformats.org/drawingml/2006/main" lIns="0" tIns="0" rIns="0" bIns="0" anchor="t">
-            <a:normAutofit fontScale="76694"/>
+            <a:normAutofit fontScale="78648"/>
           </a:bodyPr>
           <a:lstStyle xmlns:a="http://schemas.openxmlformats.org/drawingml/2006/main"/>
           <a:p xmlns:a="http://schemas.openxmlformats.org/drawingml/2006/main">
@@ -3758,7 +3718,7 @@
                 <a:ea typeface="Arial"/>
                 <a:cs typeface="Arial"/>
               </a:rPr>
-              <a:t>Orders, products, plants</a:t>
+              <a:t>Orders, lines, and loads</a:t>
             </a:r>
           </a:p>
         </p:txBody>
@@ -3820,7 +3780,7 @@
                 <a:ea typeface="Arial"/>
                 <a:cs typeface="Arial"/>
               </a:rPr>
-              <a:t>demand and promised dates</a:t>
+              <a:t>demand, value, and service rules</a:t>
             </a:r>
           </a:p>
           <a:p xmlns:a="http://schemas.openxmlformats.org/drawingml/2006/main">
@@ -3847,7 +3807,7 @@
                 <a:ea typeface="Arial"/>
                 <a:cs typeface="Arial"/>
               </a:rPr>
-              <a:t>available-to-promise (ATP) inventory</a:t>
+              <a:t>eligible DC/date alternatives</a:t>
             </a:r>
           </a:p>
           <a:p xmlns:a="http://schemas.openxmlformats.org/drawingml/2006/main">
@@ -3874,7 +3834,7 @@
                 <a:ea typeface="Arial"/>
                 <a:cs typeface="Arial"/>
               </a:rPr>
-              <a:t>eligible fulfillment options</a:t>
+              <a:t>protected cumulative ATP</a:t>
             </a:r>
           </a:p>
           <a:p xmlns:a="http://schemas.openxmlformats.org/drawingml/2006/main">
@@ -3901,7 +3861,7 @@
                 <a:ea typeface="Arial"/>
                 <a:cs typeface="Arial"/>
               </a:rPr>
-              <a:t>transport, transfer, and lateness costs</a:t>
+              <a:t>dock and optional resource limits</a:t>
             </a:r>
           </a:p>
         </p:txBody>
@@ -4095,7 +4055,7 @@
                 <a:ea typeface="Arial"/>
                 <a:cs typeface="Arial"/>
               </a:rPr>
-              <a:t>Choose at most one option per group</a:t>
+              <a:t>Choose one outcome per order group</a:t>
             </a:r>
           </a:p>
         </p:txBody>
@@ -4154,7 +4114,7 @@
                 <a:ea typeface="Arial"/>
                 <a:cs typeface="Arial"/>
               </a:rPr>
-              <a:t>xᵢⱼ ∈ {0,1}</a:t>
+              <a:t>xgc ∈ {0,1}</a:t>
             </a:r>
           </a:p>
         </p:txBody>
@@ -4213,7 +4173,7 @@
                 <a:ea typeface="Arial"/>
                 <a:cs typeface="Arial"/>
               </a:rPr>
-              <a:t>1 when option j is assigned to order group i; 0 otherwise.</a:t>
+              <a:t>1 when group g selects candidate c; 0 otherwise.</a:t>
             </a:r>
           </a:p>
         </p:txBody>
@@ -4248,7 +4208,7 @@
         </p:spPr>
         <p:txBody>
           <a:bodyPr xmlns:a="http://schemas.openxmlformats.org/drawingml/2006/main" lIns="0" tIns="0" rIns="0" bIns="0" anchor="t">
-            <a:normAutofit fontScale="92556"/>
+            <a:normAutofit fontScale="93838"/>
           </a:bodyPr>
           <a:lstStyle xmlns:a="http://schemas.openxmlformats.org/drawingml/2006/main"/>
           <a:p xmlns:a="http://schemas.openxmlformats.org/drawingml/2006/main">
@@ -4272,7 +4232,7 @@
                 <a:ea typeface="Arial"/>
                 <a:cs typeface="Arial"/>
               </a:rPr>
-              <a:t>Unfilled demand is allowed, but penalized.</a:t>
+              <a:t>Unfilled demand is explicit and penalized.</a:t>
             </a:r>
           </a:p>
         </p:txBody>
@@ -4466,7 +4426,7 @@
                 <a:ea typeface="Arial"/>
                 <a:cs typeface="Arial"/>
               </a:rPr>
-              <a:t>Maximize service value</a:t>
+              <a:t>Maximize validated service value</a:t>
             </a:r>
           </a:p>
         </p:txBody>
@@ -4525,7 +4485,7 @@
                 <a:ea typeface="Arial"/>
                 <a:cs typeface="Arial"/>
               </a:rPr>
-              <a:t>value − shipping − transfer</a:t>
+              <a:t>fulfilled value − shipping</a:t>
             </a:r>
           </a:p>
           <a:p xmlns:a="http://schemas.openxmlformats.org/drawingml/2006/main">
@@ -4549,7 +4509,7 @@
                 <a:ea typeface="Arial"/>
                 <a:cs typeface="Arial"/>
               </a:rPr>
-              <a:t>− lateness − unfilled penalty</a:t>
+              <a:t>− thresholded unmet penalty</a:t>
             </a:r>
           </a:p>
         </p:txBody>
@@ -4667,14 +4627,14 @@
                 <a:ea typeface="Arial"/>
                 <a:cs typeface="Arial"/>
               </a:rPr>
-              <a:t>ATP limits  •  plant capacity  •  option eligibility  •  one option per group</a:t>
+              <a:t>cumulative ATP  •  capacity  •  eligibility  •  load cohesion  •  integer balance</a:t>
             </a:r>
           </a:p>
         </p:txBody>
       </p:sp>
       <p:cxnSp>
         <p:nvCxnSpPr>
-          <p:cNvPr id="105" name=""/>
+          <p:cNvPr id="155" name=""/>
           <p:cNvCxnSpPr>
             <a:stCxn xmlns:a="http://schemas.openxmlformats.org/drawingml/2006/main" id="7" idx="3"/>
             <a:endCxn xmlns:a="http://schemas.openxmlformats.org/drawingml/2006/main" id="12" idx="1"/>
@@ -4700,7 +4660,7 @@
       </p:cxnSp>
       <p:cxnSp>
         <p:nvCxnSpPr>
-          <p:cNvPr id="106" name=""/>
+          <p:cNvPr id="156" name=""/>
           <p:cNvCxnSpPr>
             <a:stCxn xmlns:a="http://schemas.openxmlformats.org/drawingml/2006/main" id="12" idx="3"/>
             <a:endCxn xmlns:a="http://schemas.openxmlformats.org/drawingml/2006/main" id="19" idx="1"/>
@@ -4872,7 +4832,7 @@
                 <a:ea typeface="Arial"/>
                 <a:cs typeface="Arial"/>
               </a:rPr>
-              <a:t>Inventory couples many groups. Improving one allocation can require coordinated changes elsewhere—exactly the failure mode that local search and quantum neighborhoods target.</a:t>
+              <a:t>Shared inventory couples groups. The solver must preserve a feasible incumbent while coordinated local search reopens only the decisions that interact.</a:t>
             </a:r>
           </a:p>
         </p:txBody>
@@ -5168,7 +5128,7 @@
                 <a:ea typeface="Arial"/>
                 <a:cs typeface="Arial"/>
               </a:rPr>
-              <a:t>The hybrid solver keeps feasibility deterministic</a:t>
+              <a:t>The solver hierarchy keeps feasibility deterministic</a:t>
             </a:r>
           </a:p>
         </p:txBody>
@@ -5417,7 +5377,7 @@
                 <a:ea typeface="Arial"/>
                 <a:cs typeface="Arial"/>
               </a:rPr>
-              <a:t>Schema, domains, ATP and capacity</a:t>
+              <a:t>Schema, dates, domains, ATP, capacity</a:t>
             </a:r>
           </a:p>
         </p:txBody>
@@ -5576,7 +5536,7 @@
                 <a:ea typeface="Arial"/>
                 <a:cs typeface="Arial"/>
               </a:rPr>
-              <a:t>Greedy or HiGHS feasible incumbent</a:t>
+              <a:t>Load-atomic greedy feasible incumbent</a:t>
             </a:r>
           </a:p>
         </p:txBody>
@@ -5735,7 +5695,7 @@
                 <a:ea typeface="Arial"/>
                 <a:cs typeface="Arial"/>
               </a:rPr>
-              <a:t>Restricted MILP fixes obvious losses</a:t>
+              <a:t>Exact policy recourse optimizes quantities</a:t>
             </a:r>
           </a:p>
         </p:txBody>
@@ -5894,7 +5854,7 @@
                 <a:ea typeface="Arial"/>
                 <a:cs typeface="Arial"/>
               </a:rPr>
-              <a:t>Exact or QAOA-sampled neighborhood</a:t>
+              <a:t>Exact LNS or sampled QUBO proposal</a:t>
             </a:r>
           </a:p>
         </p:txBody>
@@ -6053,14 +6013,14 @@
                 <a:ea typeface="Arial"/>
                 <a:cs typeface="Arial"/>
               </a:rPr>
-              <a:t>Deterministic recourse and final validator</a:t>
+              <a:t>Exact recourse + independent validator</a:t>
             </a:r>
           </a:p>
         </p:txBody>
       </p:sp>
       <p:cxnSp>
         <p:nvCxnSpPr>
-          <p:cNvPr id="110" name=""/>
+          <p:cNvPr id="156" name=""/>
           <p:cNvCxnSpPr>
             <a:stCxn xmlns:a="http://schemas.openxmlformats.org/drawingml/2006/main" id="5" idx="3"/>
             <a:endCxn xmlns:a="http://schemas.openxmlformats.org/drawingml/2006/main" id="8" idx="1"/>
@@ -6086,7 +6046,7 @@
       </p:cxnSp>
       <p:cxnSp>
         <p:nvCxnSpPr>
-          <p:cNvPr id="111" name=""/>
+          <p:cNvPr id="157" name=""/>
           <p:cNvCxnSpPr>
             <a:stCxn xmlns:a="http://schemas.openxmlformats.org/drawingml/2006/main" id="8" idx="3"/>
             <a:endCxn xmlns:a="http://schemas.openxmlformats.org/drawingml/2006/main" id="11" idx="1"/>
@@ -6112,7 +6072,7 @@
       </p:cxnSp>
       <p:cxnSp>
         <p:nvCxnSpPr>
-          <p:cNvPr id="112" name=""/>
+          <p:cNvPr id="158" name=""/>
           <p:cNvCxnSpPr>
             <a:stCxn xmlns:a="http://schemas.openxmlformats.org/drawingml/2006/main" id="11" idx="3"/>
             <a:endCxn xmlns:a="http://schemas.openxmlformats.org/drawingml/2006/main" id="14" idx="1"/>
@@ -6138,7 +6098,7 @@
       </p:cxnSp>
       <p:cxnSp>
         <p:nvCxnSpPr>
-          <p:cNvPr id="113" name=""/>
+          <p:cNvPr id="159" name=""/>
           <p:cNvCxnSpPr>
             <a:stCxn xmlns:a="http://schemas.openxmlformats.org/drawingml/2006/main" id="14" idx="3"/>
             <a:endCxn xmlns:a="http://schemas.openxmlformats.org/drawingml/2006/main" id="17" idx="1"/>
@@ -6893,7 +6853,7 @@
                 <a:ea typeface="Arial"/>
                 <a:cs typeface="Arial"/>
               </a:rPr>
-              <a:t>warm parameters + deterministic cache</a:t>
+              <a:t>cached angles + exact controls</a:t>
             </a:r>
           </a:p>
         </p:txBody>
@@ -7105,7 +7065,7 @@
                 <a:ea typeface="Arial"/>
                 <a:cs typeface="Arial"/>
               </a:rPr>
-              <a:t>multi-seed gaps and Wilson intervals</a:t>
+              <a:t>raw quality, gaps, and Wilson intervals</a:t>
             </a:r>
           </a:p>
         </p:txBody>
@@ -7377,7 +7337,7 @@
         </p:spPr>
         <p:txBody>
           <a:bodyPr xmlns:a="http://schemas.openxmlformats.org/drawingml/2006/main" lIns="0" tIns="0" rIns="0" bIns="0" anchor="t">
-            <a:normAutofit fontScale="81528"/>
+            <a:normAutofit fontScale="100000"/>
           </a:bodyPr>
           <a:lstStyle xmlns:a="http://schemas.openxmlformats.org/drawingml/2006/main"/>
           <a:p xmlns:a="http://schemas.openxmlformats.org/drawingml/2006/main">
@@ -7401,7 +7361,7 @@
                 <a:ea typeface="Arial"/>
                 <a:cs typeface="Arial"/>
               </a:rPr>
-              <a:t>On the real 20-group subset, polish reaches the exact objective</a:t>
+              <a:t>Greedy captures most of the gain in 0.58 s</a:t>
             </a:r>
           </a:p>
         </p:txBody>
@@ -7546,11 +7506,12 @@
           <p:nvPr/>
         </p:nvPicPr>
         <p:blipFill>
-          <a:blip xmlns:r="http://schemas.openxmlformats.org/officeDocument/2006/relationships" xmlns:a="http://schemas.openxmlformats.org/drawingml/2006/main" r:embed="R4a3df459743a41cd"/>
+          <a:blip xmlns:r="http://schemas.openxmlformats.org/officeDocument/2006/relationships" xmlns:a="http://schemas.openxmlformats.org/drawingml/2006/main" r:embed="R0f75db5309dd4806"/>
+          <a:srcRect xmlns:a="http://schemas.openxmlformats.org/drawingml/2006/main" l="0" t="0" r="0" b="0"/>
           <a:stretch xmlns:a="http://schemas.openxmlformats.org/drawingml/2006/main"/>
         </p:blipFill>
         <p:spPr>
-          <a:xfrm xmlns:a="http://schemas.openxmlformats.org/drawingml/2006/main">
+          <a:xfrm xmlns:a="http://schemas.openxmlformats.org/drawingml/2006/main" flipH="0" flipV="0">
             <a:off x="571500" y="2390589"/>
             <a:ext cx="7124700" cy="2562598"/>
           </a:xfrm>
@@ -7654,7 +7615,7 @@
                 <a:ea typeface="Arial"/>
                 <a:cs typeface="Arial"/>
               </a:rPr>
-              <a:t>64.90%</a:t>
+              <a:t>76.83%</a:t>
             </a:r>
           </a:p>
         </p:txBody>
@@ -7713,7 +7674,7 @@
                 <a:ea typeface="Arial"/>
                 <a:cs typeface="Arial"/>
               </a:rPr>
-              <a:t>objective capture after polishing</a:t>
+              <a:t>objective capture after exact polish</a:t>
             </a:r>
           </a:p>
         </p:txBody>
@@ -7813,7 +7774,7 @@
                 <a:ea typeface="Arial"/>
                 <a:cs typeface="Arial"/>
               </a:rPr>
-              <a:t>68.50%</a:t>
+              <a:t>79.91%</a:t>
             </a:r>
           </a:p>
         </p:txBody>
@@ -7872,7 +7833,7 @@
                 <a:ea typeface="Arial"/>
                 <a:cs typeface="Arial"/>
               </a:rPr>
-              <a:t>demand fill rate</a:t>
+              <a:t>case fill rate</a:t>
             </a:r>
           </a:p>
         </p:txBody>
@@ -7972,7 +7933,7 @@
                 <a:ea typeface="Arial"/>
                 <a:cs typeface="Arial"/>
               </a:rPr>
-              <a:t>2.86 s</a:t>
+              <a:t>2.05 s</a:t>
             </a:r>
           </a:p>
         </p:txBody>
@@ -8031,7 +7992,7 @@
                 <a:ea typeface="Arial"/>
                 <a:cs typeface="Arial"/>
               </a:rPr>
-              <a:t>polished median runtime</a:t>
+              <a:t>polished-greedy runtime</a:t>
             </a:r>
           </a:p>
         </p:txBody>
@@ -8190,7 +8151,7 @@
                 <a:ea typeface="Arial"/>
                 <a:cs typeface="Arial"/>
               </a:rPr>
-              <a:t>numeric residual violations</a:t>
+              <a:t>validator residual violations</a:t>
             </a:r>
           </a:p>
         </p:txBody>
@@ -8260,7 +8221,7 @@
         </p:spPr>
         <p:txBody>
           <a:bodyPr xmlns:a="http://schemas.openxmlformats.org/drawingml/2006/main" lIns="0" tIns="0" rIns="0" bIns="0" anchor="t">
-            <a:normAutofit fontScale="100000"/>
+            <a:normAutofit fontScale="78552"/>
           </a:bodyPr>
           <a:lstStyle xmlns:a="http://schemas.openxmlformats.org/drawingml/2006/main"/>
           <a:p xmlns:a="http://schemas.openxmlformats.org/drawingml/2006/main">
@@ -8284,7 +8245,7 @@
                 <a:ea typeface="Arial"/>
                 <a:cs typeface="Arial"/>
               </a:rPr>
-              <a:t>+197.2 on the coordinated trap</a:t>
+              <a:t>+197.2 on the synthetic coordination trap</a:t>
             </a:r>
           </a:p>
         </p:txBody>
@@ -8343,7 +8304,7 @@
                 <a:ea typeface="Arial"/>
                 <a:cs typeface="Arial"/>
               </a:rPr>
-              <a:t>Exact LNS and the hybrid escape the greedy basin; this is the strongest evidence for coordinated neighborhoods.</a:t>
+              <a:t>Exact LNS and QAOA proposals recover the same coordinated gain after exact recourse.</a:t>
             </a:r>
           </a:p>
         </p:txBody>
@@ -8402,7 +8363,7 @@
                 <a:ea typeface="Arial"/>
                 <a:cs typeface="Arial"/>
               </a:rPr>
-              <a:t>Objective capture = achieved objective ÷ total requested merchandise value; it is not an optimality gap.</a:t>
+              <a:t>Greedy adds +1.86 pp capture vs default; the time-limited full MILP retains a nonzero gap.</a:t>
             </a:r>
           </a:p>
         </p:txBody>
@@ -8492,7 +8453,7 @@
                 <a:ea typeface="Arial"/>
                 <a:cs typeface="Arial"/>
               </a:rPr>
-              <a:t>Evidence: results/final/tables/solver_comparison.csv • synthetic_coordination_control.csv</a:t>
+              <a:t>Evidence: results/final/figures/submission_solver_summary.png • submission_coordination_summary.png</a:t>
             </a:r>
           </a:p>
         </p:txBody>
@@ -8674,7 +8635,7 @@
         </p:spPr>
         <p:txBody>
           <a:bodyPr xmlns:a="http://schemas.openxmlformats.org/drawingml/2006/main" lIns="0" tIns="0" rIns="0" bIns="0" anchor="t">
-            <a:normAutofit fontScale="88923"/>
+            <a:normAutofit fontScale="100000"/>
           </a:bodyPr>
           <a:lstStyle xmlns:a="http://schemas.openxmlformats.org/drawingml/2006/main"/>
           <a:p xmlns:a="http://schemas.openxmlformats.org/drawingml/2006/main">
@@ -8698,7 +8659,7 @@
                 <a:ea typeface="Arial"/>
                 <a:cs typeface="Arial"/>
               </a:rPr>
-              <a:t>HiGHS stays portable; exact methods are escalation tools</a:t>
+              <a:t>Bounded search scales through all 372 real groups</a:t>
             </a:r>
           </a:p>
         </p:txBody>
@@ -8843,11 +8804,12 @@
           <p:nvPr/>
         </p:nvPicPr>
         <p:blipFill>
-          <a:blip xmlns:r="http://schemas.openxmlformats.org/officeDocument/2006/relationships" xmlns:a="http://schemas.openxmlformats.org/drawingml/2006/main" r:embed="Rbac442c718124714"/>
+          <a:blip xmlns:r="http://schemas.openxmlformats.org/officeDocument/2006/relationships" xmlns:a="http://schemas.openxmlformats.org/drawingml/2006/main" r:embed="R286f0a84b20c4cc7"/>
+          <a:srcRect xmlns:a="http://schemas.openxmlformats.org/drawingml/2006/main" l="0" t="0" r="0" b="0"/>
           <a:stretch xmlns:a="http://schemas.openxmlformats.org/drawingml/2006/main"/>
         </p:blipFill>
         <p:spPr>
-          <a:xfrm xmlns:a="http://schemas.openxmlformats.org/drawingml/2006/main">
+          <a:xfrm xmlns:a="http://schemas.openxmlformats.org/drawingml/2006/main" flipH="0" flipV="0">
             <a:off x="581025" y="1966424"/>
             <a:ext cx="6877050" cy="3553801"/>
           </a:xfrm>
@@ -8980,7 +8942,7 @@
                 <a:ea typeface="Arial"/>
                 <a:cs typeface="Arial"/>
               </a:rPr>
-              <a:t>DEFAULT</a:t>
+              <a:t>FAST</a:t>
             </a:r>
           </a:p>
         </p:txBody>
@@ -9039,7 +9001,7 @@
                 <a:ea typeface="Arial"/>
                 <a:cs typeface="Arial"/>
               </a:rPr>
-              <a:t>SciPy + HiGHS</a:t>
+              <a:t>Greedy</a:t>
             </a:r>
           </a:p>
         </p:txBody>
@@ -9098,7 +9060,7 @@
                 <a:ea typeface="Arial"/>
                 <a:cs typeface="Arial"/>
               </a:rPr>
-              <a:t>Open-source, cross-platform, and always used unless another backend is explicitly requested.</a:t>
+              <a:t>1.31 s median at all 372 groups; feasible incumbent for every planning run.</a:t>
             </a:r>
           </a:p>
         </p:txBody>
@@ -9227,7 +9189,7 @@
                 <a:ea typeface="Arial"/>
                 <a:cs typeface="Arial"/>
               </a:rPr>
-              <a:t>OPTIONAL</a:t>
+              <a:t>QUALITY</a:t>
             </a:r>
           </a:p>
         </p:txBody>
@@ -9286,7 +9248,7 @@
                 <a:ea typeface="Arial"/>
                 <a:cs typeface="Arial"/>
               </a:rPr>
-              <a:t>Gurobi parity</a:t>
+              <a:t>Exact LNS</a:t>
             </a:r>
           </a:p>
         </p:txBody>
@@ -9345,7 +9307,7 @@
                 <a:ea typeface="Arial"/>
                 <a:cs typeface="Arial"/>
               </a:rPr>
-              <a:t>A licensed benchmark path; never required and never selected silently.</a:t>
+              <a:t>26.14 s median and the strongest full-scope capture in the repeated study.</a:t>
             </a:r>
           </a:p>
         </p:txBody>
@@ -9474,7 +9436,7 @@
                 <a:ea typeface="Arial"/>
                 <a:cs typeface="Arial"/>
               </a:rPr>
-              <a:t>ESCALATE</a:t>
+              <a:t>HYBRID</a:t>
             </a:r>
           </a:p>
         </p:txBody>
@@ -9533,7 +9495,7 @@
                 <a:ea typeface="Arial"/>
                 <a:cs typeface="Arial"/>
               </a:rPr>
-              <a:t>Exact LNS / quantum</a:t>
+              <a:t>Fixed-width QUBO</a:t>
             </a:r>
           </a:p>
         </p:txBody>
@@ -9592,7 +9554,7 @@
                 <a:ea typeface="Arial"/>
                 <a:cs typeface="Arial"/>
               </a:rPr>
-              <a:t>Spend extra compute only on hard, coupled neighborhoods.</a:t>
+              <a:t>101.17 s median; at most 16 variables at full real scope.</a:t>
             </a:r>
           </a:p>
         </p:txBody>
@@ -9651,7 +9613,7 @@
                 <a:ea typeface="Arial"/>
                 <a:cs typeface="Arial"/>
               </a:rPr>
-              <a:t>At 372 groups: greedy ≈16.7 s • polished ≈54.6 s • exact LNS ≈74.0 s (medians).</a:t>
+              <a:t>Generated: greedy + exact LNS reach 100k orders; hybrid reaches 20k with a 32-variable QUBO.</a:t>
             </a:r>
           </a:p>
         </p:txBody>
@@ -9741,7 +9703,7 @@
                 <a:ea typeface="Arial"/>
                 <a:cs typeface="Arial"/>
               </a:rPr>
-              <a:t>Evidence: results/final/tables/size_scaling.csv • optional backend experiment in notebooks/nestle_challenge_experiments.ipynb</a:t>
+              <a:t>Evidence: results/final/figures/submission_scaling_summary.png • notebooks/nestle_challenge_experiments.ipynb</a:t>
             </a:r>
           </a:p>
         </p:txBody>
@@ -9923,7 +9885,7 @@
         </p:spPr>
         <p:txBody>
           <a:bodyPr xmlns:a="http://schemas.openxmlformats.org/drawingml/2006/main" lIns="0" tIns="0" rIns="0" bIns="0" anchor="t">
-            <a:normAutofit fontScale="84999"/>
+            <a:normAutofit fontScale="100000"/>
           </a:bodyPr>
           <a:lstStyle xmlns:a="http://schemas.openxmlformats.org/drawingml/2006/main"/>
           <a:p xmlns:a="http://schemas.openxmlformats.org/drawingml/2006/main">
@@ -9947,7 +9909,7 @@
                 <a:ea typeface="Arial"/>
                 <a:cs typeface="Arial"/>
               </a:rPr>
-              <a:t>Hardware evidence favors shallow, constraint-aware circuits</a:t>
+              <a:t>Shallow QAOA better preserves feasibility</a:t>
             </a:r>
           </a:p>
         </p:txBody>
@@ -10092,11 +10054,12 @@
           <p:nvPr/>
         </p:nvPicPr>
         <p:blipFill>
-          <a:blip xmlns:r="http://schemas.openxmlformats.org/officeDocument/2006/relationships" xmlns:a="http://schemas.openxmlformats.org/drawingml/2006/main" r:embed="R55f2de284df2437a"/>
+          <a:blip xmlns:r="http://schemas.openxmlformats.org/officeDocument/2006/relationships" xmlns:a="http://schemas.openxmlformats.org/drawingml/2006/main" r:embed="R4a168ebe6ada4cea"/>
+          <a:srcRect xmlns:a="http://schemas.openxmlformats.org/drawingml/2006/main" l="0" t="0" r="0" b="0"/>
           <a:stretch xmlns:a="http://schemas.openxmlformats.org/drawingml/2006/main"/>
         </p:blipFill>
         <p:spPr>
-          <a:xfrm xmlns:a="http://schemas.openxmlformats.org/drawingml/2006/main">
+          <a:xfrm xmlns:a="http://schemas.openxmlformats.org/drawingml/2006/main" flipH="0" flipV="0">
             <a:off x="590550" y="2165164"/>
             <a:ext cx="6896100" cy="2794372"/>
           </a:xfrm>
@@ -10259,7 +10222,7 @@
                 <a:ea typeface="Arial"/>
                 <a:cs typeface="Arial"/>
               </a:rPr>
-              <a:t>122 two-qubit gates • depth 138</a:t>
+              <a:t>40 two-qubit gates • depth 43</a:t>
             </a:r>
           </a:p>
         </p:txBody>
@@ -10359,7 +10322,7 @@
                 <a:ea typeface="Arial"/>
                 <a:cs typeface="Arial"/>
               </a:rPr>
-              <a:t>50.8–59.0%</a:t>
+              <a:t>65.34%</a:t>
             </a:r>
           </a:p>
         </p:txBody>
@@ -10418,7 +10381,7 @@
                 <a:ea typeface="Arial"/>
                 <a:cs typeface="Arial"/>
               </a:rPr>
-              <a:t>median raw one-hot validity</a:t>
+              <a:t>median raw one-hot feasibility</a:t>
             </a:r>
           </a:p>
         </p:txBody>
@@ -10577,7 +10540,7 @@
                 <a:ea typeface="Arial"/>
                 <a:cs typeface="Arial"/>
               </a:rPr>
-              <a:t>420 two-qubit gates • depth 458</a:t>
+              <a:t>373 two-qubit gates • depth 448</a:t>
             </a:r>
           </a:p>
         </p:txBody>
@@ -10677,7 +10640,7 @@
                 <a:ea typeface="Arial"/>
                 <a:cs typeface="Arial"/>
               </a:rPr>
-              <a:t>12.1–15.2%</a:t>
+              <a:t>10.36%</a:t>
             </a:r>
           </a:p>
         </p:txBody>
@@ -10736,7 +10699,7 @@
                 <a:ea typeface="Arial"/>
                 <a:cs typeface="Arial"/>
               </a:rPr>
-              <a:t>median raw one-hot validity</a:t>
+              <a:t>median raw one-hot feasibility</a:t>
             </a:r>
           </a:p>
         </p:txBody>
@@ -10865,7 +10828,7 @@
         </p:spPr>
         <p:txBody>
           <a:bodyPr xmlns:a="http://schemas.openxmlformats.org/drawingml/2006/main" lIns="0" tIns="0" rIns="0" bIns="0" anchor="t">
-            <a:normAutofit fontScale="91663"/>
+            <a:normAutofit fontScale="100000"/>
           </a:bodyPr>
           <a:lstStyle xmlns:a="http://schemas.openxmlformats.org/drawingml/2006/main"/>
           <a:p xmlns:a="http://schemas.openxmlformats.org/drawingml/2006/main">
@@ -10889,7 +10852,7 @@
                 <a:ea typeface="Arial"/>
                 <a:cs typeface="Arial"/>
               </a:rPr>
-              <a:t>Deeper ideal QAOA improves, but hardware noise overwhelms the benefit. Recourse restores final feasibility.</a:t>
+              <a:t>p=1 exact hit: 0.684% vs 0.391% uniform control. Exact recourse validates every final plan.</a:t>
             </a:r>
           </a:p>
         </p:txBody>
@@ -10948,7 +10911,7 @@
                 <a:ea typeface="Arial"/>
                 <a:cs typeface="Arial"/>
               </a:rPr>
-              <a:t>No quantum-advantage claim: 18 QPU jobs are evidence of execution and failure modes, not superiority. Archived runs predate the strengthened W-state/path-mixer implementation.</a:t>
+              <a:t>18 QPU jobs • 8,192 shots/job • runtime uses a log scale because queue outliers reach about 12,021 s.</a:t>
             </a:r>
           </a:p>
         </p:txBody>
@@ -11038,7 +11001,7 @@
                 <a:ea typeface="Arial"/>
                 <a:cs typeface="Arial"/>
               </a:rPr>
-              <a:t>Evidence: results/final/ibm • strengthened circuit code: src/domopt/quantum.py and src/domopt/hardware.py</a:t>
+              <a:t>Evidence: results/final/figures/submission_ibm_depth_summary.png • results/final/ibm/figures/ibm_hardware_stress.png</a:t>
             </a:r>
           </a:p>
         </p:txBody>
@@ -11220,7 +11183,7 @@
         </p:spPr>
         <p:txBody>
           <a:bodyPr xmlns:a="http://schemas.openxmlformats.org/drawingml/2006/main" lIns="0" tIns="0" rIns="0" bIns="0" anchor="t">
-            <a:normAutofit fontScale="81597"/>
+            <a:normAutofit fontScale="100000"/>
           </a:bodyPr>
           <a:lstStyle xmlns:a="http://schemas.openxmlformats.org/drawingml/2006/main"/>
           <a:p xmlns:a="http://schemas.openxmlformats.org/drawingml/2006/main">
@@ -11244,7 +11207,7 @@
                 <a:ea typeface="Arial"/>
                 <a:cs typeface="Arial"/>
               </a:rPr>
-              <a:t>Deploy the hybrid now; treat quantum as a measured R&amp;D lane</a:t>
+              <a:t>Deploy classical now; measure QAOA</a:t>
             </a:r>
           </a:p>
         </p:txBody>
@@ -11590,7 +11553,7 @@
                 <a:ea typeface="Arial"/>
                 <a:cs typeface="Arial"/>
               </a:rPr>
-              <a:t>Use polished HiGHS as the portable default.</a:t>
+              <a:t>FAST: release polished greedy after certification.</a:t>
             </a:r>
           </a:p>
           <a:p xmlns:a="http://schemas.openxmlformats.org/drawingml/2006/main">
@@ -11617,7 +11580,7 @@
                 <a:ea typeface="Arial"/>
                 <a:cs typeface="Arial"/>
               </a:rPr>
-              <a:t>Trigger exact LNS only when coupling or stagnation is detected.</a:t>
+              <a:t>QUALITY: trigger exact LNS for material conflicts.</a:t>
             </a:r>
           </a:p>
           <a:p xmlns:a="http://schemas.openxmlformats.org/drawingml/2006/main">
@@ -11644,7 +11607,7 @@
                 <a:ea typeface="Arial"/>
                 <a:cs typeface="Arial"/>
               </a:rPr>
-              <a:t>Benchmark Gurobi only when licensed; require objective parity.</a:t>
+              <a:t>CERTIFY: validate every plan and record residuals.</a:t>
             </a:r>
           </a:p>
           <a:p xmlns:a="http://schemas.openxmlformats.org/drawingml/2006/main">
@@ -11671,7 +11634,7 @@
                 <a:ea typeface="Arial"/>
                 <a:cs typeface="Arial"/>
               </a:rPr>
-              <a:t>Log provenance, feasibility, gaps, and sampler quality on every run.</a:t>
+              <a:t>COPILOT: review changes, rationale, and downloads.</a:t>
             </a:r>
           </a:p>
         </p:txBody>
@@ -11918,7 +11881,7 @@
                 <a:ea typeface="Arial"/>
                 <a:cs typeface="Arial"/>
               </a:rPr>
-              <a:t>Operational tuning</a:t>
+              <a:t>Shadow-mode pilot</a:t>
             </a:r>
           </a:p>
         </p:txBody>
@@ -11977,7 +11940,7 @@
                 <a:ea typeface="Arial"/>
                 <a:cs typeface="Arial"/>
               </a:rPr>
-              <a:t>Scenario stress tests • calibrate penalties • automated hard-neighborhood detection</a:t>
+              <a:t>Confirm DCs, calendars, capacity • measure planner acceptance and realized service</a:t>
             </a:r>
           </a:p>
         </p:txBody>
@@ -12165,7 +12128,7 @@
                 <a:ea typeface="Arial"/>
                 <a:cs typeface="Arial"/>
               </a:rPr>
-              <a:t>Search efficiency</a:t>
+              <a:t>Scalable search</a:t>
             </a:r>
           </a:p>
         </p:txBody>
@@ -12224,7 +12187,7 @@
                 <a:ea typeface="Arial"/>
                 <a:cs typeface="Arial"/>
               </a:rPr>
-              <a:t>Parallel LNS • adaptive neighborhood size • incumbent diversity • warm starts</a:t>
+              <a:t>Adaptive LNS • rolling uncertainty • solver-engine benchmark • learned conflicts</a:t>
             </a:r>
           </a:p>
         </p:txBody>
@@ -12412,7 +12375,7 @@
                 <a:ea typeface="Arial"/>
                 <a:cs typeface="Arial"/>
               </a:rPr>
-              <a:t>Quantum evidence</a:t>
+              <a:t>Bounded QAOA</a:t>
             </a:r>
           </a:p>
         </p:txBody>
@@ -12471,7 +12434,7 @@
                 <a:ea typeface="Arial"/>
                 <a:cs typeface="Arial"/>
               </a:rPr>
-              <a:t>Hardware-aware topology • CVaR objectives • angle transfer • stronger mitigation</a:t>
+              <a:t>Shallow p=1 • angle transfer • sequential stopping • calibrated mitigation</a:t>
             </a:r>
           </a:p>
         </p:txBody>
@@ -12659,7 +12622,7 @@
                 <a:ea typeface="Arial"/>
                 <a:cs typeface="Arial"/>
               </a:rPr>
-              <a:t>REPRODUCIBLE</a:t>
+              <a:t>SCALABLE</a:t>
             </a:r>
           </a:p>
         </p:txBody>
@@ -12753,7 +12716,7 @@
                 <a:ea typeface="Arial"/>
                 <a:cs typeface="Arial"/>
               </a:rPr>
-              <a:t>QUANTUM CLAIMS: EVIDENCE ONLY</a:t>
+              <a:t>QAOA: BOUNDED + MEASURED</a:t>
             </a:r>
           </a:p>
         </p:txBody>
@@ -12788,7 +12751,7 @@
         </p:spPr>
         <p:txBody>
           <a:bodyPr xmlns:a="http://schemas.openxmlformats.org/drawingml/2006/main" lIns="0" tIns="0" rIns="0" bIns="0" anchor="t">
-            <a:normAutofit fontScale="71642"/>
+            <a:normAutofit fontScale="70833"/>
           </a:bodyPr>
           <a:lstStyle xmlns:a="http://schemas.openxmlformats.org/drawingml/2006/main"/>
           <a:p xmlns:a="http://schemas.openxmlformats.org/drawingml/2006/main">
@@ -12812,7 +12775,7 @@
                 <a:ea typeface="Arial"/>
                 <a:cs typeface="Arial"/>
               </a:rPr>
-              <a:t>The strongest solver is the one that improves decisions without weakening trust.</a:t>
+              <a:t>The advantage is a solver that scales now and makes every future proposal auditable.</a:t>
             </a:r>
           </a:p>
         </p:txBody>
@@ -12902,7 +12865,7 @@
                 <a:ea typeface="Arial"/>
                 <a:cs typeface="Arial"/>
               </a:rPr>
-              <a:t>Full analysis and references: reports/final_report.pdf • setup and repository map: README.md</a:t>
+              <a:t>Decision guide: reports/planner_view.pdf • challenge evidence: reports/challenge_submission_report.pdf • setup: README.md</a:t>
             </a:r>
           </a:p>
         </p:txBody>

</xml_diff>